<commit_message>
Final SEASUG 2026 materials: impersonal paper typeset in LaTeX, updated slides, README and figure fix
</commit_message>
<xml_diff>
--- a/slides/SEASUG2026_Slides_Muritala_Ghosh.pptx
+++ b/slides/SEASUG2026_Slides_Muritala_Ghosh.pptx
@@ -517,7 +517,7 @@
           <a:p>
             <a:r>
               <a:rPr lang="en-US" dirty="0"/>
-              <a:t>OPENING (20 seconds). Good morning. I am Faruk Muritala from Kennesaw State University, presenting joint work with Dr. Dhrubajyoti Ghosh. Our question is simple: if a mother smokes during pregnancy, how much does that raise the chance of a preterm birth, once we account for the fact that smokers differ from non-smokers in many other ways? we use the 2023 U.S. birth certificate file, 3.26 million births, and a doubly robust method called AIPTW, short for Augmented IPTW. The program title says propensity score matching; in this talk the propensity score is used for weighting, not matching, and we will explain why on the method slide.</a:t>
+              <a:t>OPENING (20 seconds). Good morning. This presentation is joint work of Faruk Muritala and Dr. Dhrubajyoti Ghosh of Kennesaw State University. The question is simple: if a mother smokes during pregnancy, how much does that raise the chance of a preterm birth, once the differences between smokers and non-smokers in many other characteristics are accounted for? The data are the 2023 U.S. birth certificate file, 3.26 million births, and the method is a doubly robust estimator called AIPTW, short for Augmented IPTW. The program title refers to propensity score matching; in this talk the propensity score is used for weighting, and the reason is given on the method slide.</a:t>
             </a:r>
             <a:endParaRPr lang="en-US" dirty="0"/>
           </a:p>
@@ -605,7 +605,7 @@
           <a:p>
             <a:r>
               <a:rPr lang="en-US" dirty="0"/>
-              <a:t>OVERLAP AND BALANCE (40 seconds). The plot shows the estimated probability of smoking, the propensity score, on a log scale. Smokers, in orange, mostly sit between 0.03 and 0.2, with a median of 0.058. Non-smokers, in gray, have a second hump near 0.003: 40.8 percent of non-smokers have a score under 0.01, so they are very unlikely to smoke and have no real smoker counterpart. The dashed lines mark the 1st and 99th percentiles used to clamp the scores. A smoker with a very small score can receive a big weight: the largest stabilized weight is 187 and the smokers are worth an effective sample of about 6,807 out of 97,187. That widens the confidence interval for the whole-population effect, and it is why we also report the effect among smokers (ATT), which is more stable, and check results with overlap weights. After weighting, the largest standardized mean difference falls from 0.64 to 0.13, and 3 of 38 covariate levels stay slightly above the usual 0.10 threshold; the balance plot is in the backup slide.</a:t>
+              <a:t>OVERLAP AND BALANCE (40 seconds). The plot shows the estimated probability of smoking, the propensity score, on a log scale. Smokers, in orange, mostly sit between 0.03 and 0.2, with a median of 0.058. Non-smokers, in gray, have a second hump near 0.003: 40.8 percent of non-smokers have a score under 0.01, so they are very unlikely to smoke and have no real smoker counterpart. The dashed lines mark the 1st and 99th percentiles used to clamp the scores. A smoker with a very small score can receive a big weight: the largest stabilized weight is 187 and the smokers are worth an effective sample of about 6,807 out of 97,187. That widens the confidence interval for the whole-population effect. For this reason the effect among smokers (ATT), which has a narrower interval, is reported alongside, and results are checked with overlap weights. After weighting, the largest standardized mean difference falls from 0.64 to 0.13, and 3 of 38 covariate levels stay slightly above the usual 0.10 threshold; the balance plot is in the backup slide.</a:t>
             </a:r>
             <a:endParaRPr lang="en-US" dirty="0"/>
           </a:p>
@@ -693,7 +693,7 @@
           <a:p>
             <a:r>
               <a:rPr lang="en-US" dirty="0"/>
-              <a:t>RESULTS (60 seconds). The crude difference is 5.6 percentage points. After adjustment all four adjusted estimators agree closely, between 3.3 and 3.7 points, so adjustment removes roughly one-third to two-fifths of the crude gap. Our headline AIPTW estimate, the orange dot, is 3.26 percentage points, 95 percent confidence interval 2.47 to 4.04. Standardized risks are 11.6 percent if all mothers smoked and 8.4 percent if none did, a risk ratio of 1.39 and an odds ratio of 1.44. Among mothers who actually smoked, the ATT, the effect is 3.39 points, 3.17 to 3.61, a tighter interval. The E-value for the risk ratio is 2.12, and 1.92 for the lower confidence limit: an unmeasured confounder would need to raise both smoking and preterm risk about 2-fold, beyond the ten variables already in the model, to explain the whole effect away. Alcohol, cannabis, stress and interpregnancy interval are examples of unmeasured factors that could matter.</a:t>
+              <a:t>RESULTS (60 seconds). The crude difference is 5.6 percentage points. After adjustment the four adjusted estimators range from 3.3 to 3.7 points, which is one-third to two-fifths smaller than the crude gap. The primary AIPTW estimate, the orange dot, is 3.26 percentage points, 95 percent confidence interval 2.47 to 4.04. Standardized risks are 11.6 percent if all mothers smoked and 8.4 percent if none did, a risk ratio of 1.39 and an odds ratio of 1.44. Among mothers who smoked (the ATT), the effect is 3.39 points, 3.17 to 3.61, a tighter interval. The E-value for the risk ratio is 2.12, and 1.92 for the lower confidence limit: an unmeasured confounder would need to raise both smoking and preterm risk about 2-fold, beyond the ten variables already in the model, to explain the whole effect away. Alcohol, cannabis and stress are examples of factors that are not recorded in the file.</a:t>
             </a:r>
             <a:endParaRPr lang="en-US" dirty="0"/>
           </a:p>
@@ -781,7 +781,7 @@
           <a:p>
             <a:r>
               <a:rPr lang="en-US" dirty="0"/>
-              <a:t>ROBUSTNESS (30 seconds). Each dot is the AIPTW risk difference under a different choice, with its 95 percent interval. The top block changes the covariates: dropping the two variables measured during pregnancy, prenatal care and WIC, raises the estimate to 3.65; adding insurance gives 3.05; quadratic age and BMI give 3.30; adding two-way interactions gives 3.02. The bottom block changes how extreme propensity scores are handled: no truncation 3.38, clamping at 0.1 and 99.9 percent 3.39, at 1 and 99 percent 3.26 (our main analysis), at 5 and 95 percent 3.22, deleting births outside a score of 0.01 to 0.99, which keeps only 60 percent of the cohort, 3.03, and overlap weights 3.30. Every interval excludes zero and every estimate is between 3.0 and 3.7 points. The takeaway is that the headline does not hinge on one analytic choice, although the interval width does depend on the weights.</a:t>
+              <a:t>ROBUSTNESS (30 seconds). Each dot is the AIPTW risk difference under a different choice, with its 95 percent interval. The top block changes the covariates: dropping the two variables measured during pregnancy, prenatal care and WIC, raises the estimate to 3.65; adding insurance gives 3.05; quadratic age and BMI give 3.30; adding two-way interactions gives 3.02. The bottom block changes how extreme propensity scores are handled: no truncation 3.38, clamping at 0.1 and 99.9 percent 3.39, at 1 and 99 percent 3.26 (main analysis), at 5 and 95 percent 3.22, deleting births outside a score of 0.01 to 0.99, which keeps only 60 percent of the cohort, 3.03, and overlap weights 3.30. Every interval excludes zero and every estimate is between 3.0 and 3.7 points. The estimate varies little with the analytic choice, whereas the interval width depends on the weights.</a:t>
             </a:r>
             <a:endParaRPr lang="en-US" dirty="0"/>
           </a:p>
@@ -869,7 +869,7 @@
           <a:p>
             <a:r>
               <a:rPr lang="en-US" dirty="0"/>
-              <a:t>CONCLUSION (45 seconds). Under the stated assumptions, smoking in pregnancy raises the probability of preterm birth by about 3.3 percentage points in this 2023 U.S. cohort, a relative increase of about 39 percent. The result is stable across estimators and sensitivity checks. We are open about the limits: overlap is weak for some mothers; the smoking report is self-reported and probably under-reported; any smoking is a coarse exposure; some pregnancy variables such as prenatal care and WIC occur after conception and are covered in a sensitivity analysis; and unmeasured factors such as alcohol, cannabis, stress and interpregnancy interval could still bias the estimate. Next steps: flexible machine-learning nuisance models with cross-fitting, using the same AIPTW structure; dose and timing of smoking and the effect of quitting; combining several years of data; and a SAS implementation so this audience can reproduce it. All R code, with the data link and run instructions, is in the repository, with seed 1234 throughout.</a:t>
+              <a:t>CONCLUSION (45 seconds). Under the stated assumptions, the AIPTW estimate is an increase in the probability of preterm birth of about 3.3 percentage points with smoking in pregnancy in this 2023 U.S. cohort, a risk ratio of 1.39. Estimates range from 3.0 to 3.7 points across the estimators, propensity score handling rules and covariate specifications examined. The limits are: overlap is weak for some mothers; smoking is self-reported; any smoking is a coarse exposure; prenatal care and WIC are measured during pregnancy and are examined in a sensitivity analysis; and factors not recorded in the file, such as alcohol, cannabis and stress, are not adjusted for. The E-value quantifies the strength an unmeasured confounder would need. Next steps are flexible machine-learning nuisance models with cross-fitting within the same AIPTW structure; dose and timing of smoking; combining several years of data; and a SAS implementation for this audience. All R code, with the data link and run instructions, is in the repository, with seed 1234 throughout.</a:t>
             </a:r>
             <a:endParaRPr lang="en-US" dirty="0"/>
           </a:p>
@@ -957,7 +957,7 @@
           <a:p>
             <a:r>
               <a:rPr lang="en-US" dirty="0"/>
-              <a:t>CLOSING (15 seconds). Thank you for listening. If you would like to talk about causal inference with birth certificate data, or you want the code, please scan the code to connect with me on LinkedIn. I am happy to take questions now.</a:t>
+              <a:t>CLOSING (15 seconds). Thank you for listening. For discussion of causal inference with birth certificate data, or for the code, the QR code links to the first author on LinkedIn. Questions are welcome.</a:t>
             </a:r>
             <a:endParaRPr lang="en-US" dirty="0"/>
           </a:p>
@@ -1133,7 +1133,7 @@
           <a:p>
             <a:r>
               <a:rPr lang="en-US" dirty="0"/>
-              <a:t>BACKUP. Love plot of absolute standardized mean differences for all 38 covariate levels. Before weighting (orange) education, WIC, parity and prenatal care timing are far apart, up to 0.64. After stabilized IPTW (navy) nearly all are below 0.10. Three levels stay slightly above: BMI 18.5 to 24.9 at 0.13, Asian race at 0.11 and age 40 and over at 0.10. These are small groups with weak overlap and we disclose them. The AIPTW estimator adds the outcome model, which also adjusts for these covariates.</a:t>
+              <a:t>BACKUP. Love plot of absolute standardized mean differences for all 38 covariate levels. Before weighting (orange) education, WIC, parity and prenatal care timing are far apart, up to 0.64. After stabilized IPTW (navy) nearly all are below 0.10. Three levels stay slightly above: BMI 18.5 to 24.9 at 0.13, Asian race at 0.11 and age 40 and over at 0.10. These levels are reported here. The AIPTW estimator adds the outcome model, which also adjusts for these covariates.</a:t>
             </a:r>
             <a:endParaRPr lang="en-US" dirty="0"/>
           </a:p>
@@ -1221,7 +1221,7 @@
           <a:p>
             <a:r>
               <a:rPr lang="en-US" dirty="0"/>
-              <a:t>PROBLEM (30 seconds). Four numbers frame the talk. Our analytic cohort has 3,259,496 singleton births. 97,187 mothers, 3.0 percent, reported smoking during pregnancy. Overall 8.5 percent of babies were born before 37 weeks. Among smokers it is 13.9 percent and among non-smokers 8.3 percent, a raw gap of 5.6 percentage points. The raw gap is not the causal effect, because mothers who smoke also have less education, later or no prenatal care, more prior preterm births and more chronic conditions, and those things raise preterm risk by themselves. The goal is to separate the part caused by smoking from the part caused by who smokes.</a:t>
+              <a:t>PROBLEM (30 seconds). Four numbers frame the talk. The analytic cohort has 3,259,496 singleton births. 97,187 mothers, 3.0 percent, reported smoking during pregnancy. Overall 8.5 percent of babies were born before 37 weeks. Among smokers it is 13.9 percent and among non-smokers 8.3 percent, a raw gap of 5.6 percentage points. The raw gap is not the causal effect, because mothers who smoke also have less education, later or no prenatal care, more prior preterm births and more chronic conditions, and those things raise preterm risk by themselves. The goal is to separate the part attributable to smoking from the part attributable to who smokes.</a:t>
             </a:r>
             <a:endParaRPr lang="en-US" dirty="0"/>
           </a:p>
@@ -1309,7 +1309,7 @@
           <a:p>
             <a:r>
               <a:rPr lang="en-US" dirty="0"/>
-              <a:t>DATA (30 seconds). The source is the National Center for Health Statistics 2023 Natality Public Use File, which covers every U.S. birth and has no personal identifiers. We start with 3,476,180 singleton births that have a known gestational age and a known smoking status. We drop 8,501 births to mothers who do not live in the U.S., leaving 3,467,679, and then keep births with complete data on the ten confounders, which leaves 3,259,496, or 93.8 percent. The exposure is any smoking reported during pregnancy. The outcome is preterm birth, under 37 completed weeks by the obstetric estimate. The ten confounders were chosen from the DAG, which we show shortly. Insurance type was left out of the main model and used only as a sensitivity check. Link and run instructions for the data are at the top of the R code.</a:t>
+              <a:t>DATA (30 seconds). The source is the National Center for Health Statistics 2023 Natality Public Use File, which covers every U.S. birth and has no personal identifiers. The file contains 3,476,180 singleton births that have a known gestational age and a known smoking status. 8,501 births to mothers who do not live in the U.S. are dropped, leaving 3,467,679, and births with complete data on the ten confounders are kept, which leaves 3,259,496, or 93.8 percent. The exposure is any smoking reported during pregnancy. The outcome is preterm birth, under 37 completed weeks by the obstetric estimate. The ten confounders were chosen from the DAG, shown shortly. Insurance type was left out of the main model and used only as a sensitivity check. Link and run instructions for the data are at the top of the R code.</a:t>
             </a:r>
             <a:endParaRPr lang="en-US" dirty="0"/>
           </a:p>
@@ -1485,7 +1485,7 @@
           <a:p>
             <a:r>
               <a:rPr lang="en-US" dirty="0"/>
-              <a:t>EDA, OUTCOME (30 seconds). The histogram shows gestational age at delivery. The whole distribution for smokers is shifted to the left: fewer births at 39 and 40 weeks, more at 34 to 38. The mean is 37.97 weeks for smokers and 38.45 for non-smokers. The preterm share is 13.9 versus 8.3 percent. Notice the other risk factors in the bullets: among non-smokers, a prior preterm birth carries a 26.1 percent preterm risk against 7.6 percent without one, pre-pregnancy diabetes 26.1 percent, hypertension 19.9 percent. Those same factors are more common in smokers, 8.9 percent have a prior preterm birth versus 3.7 percent of non-smokers. This is exactly what confounding looks like in data, and why we adjust.</a:t>
+              <a:t>EDA, OUTCOME (30 seconds). The histogram shows gestational age at delivery. The whole distribution for smokers is shifted to the left: fewer births at 39 and 40 weeks, more at 34 to 38. The mean is 37.97 weeks for smokers and 38.45 for non-smokers. The preterm share is 13.9 versus 8.3 percent. Notice the other risk factors in the bullets: among non-smokers, a prior preterm birth carries a 26.1 percent preterm risk against 7.6 percent without one, pre-pregnancy diabetes 26.1 percent, hypertension 19.9 percent. Those same factors are more common in smokers: 8.9 percent have a prior preterm birth versus 3.7 percent of non-smokers. This pattern is the signature of confounding, and the reason for adjustment.</a:t>
             </a:r>
             <a:endParaRPr lang="en-US" dirty="0"/>
           </a:p>
@@ -1573,7 +1573,7 @@
           <a:p>
             <a:r>
               <a:rPr lang="en-US" dirty="0"/>
-              <a:t>LITERATURE (45 seconds). On the left is what has been done. Smoking raises preterm risk: the largest U.S. study, Liu and colleagues in PLOS Medicine 2020, used about 25.6 million births and found odds ratios from 1.31 at one or two cigarettes a day to 1.53 at twenty or more in the first trimester, building on earlier meta-analysis by Shah and Bracken. Stronger causal designs, such as sibling comparisons, Mendelian randomization and cigarette-tax instruments, mostly study birth weight or fetal growth rather than gestational age. Propensity score methods have been used for birth weight, and doubly robust and weighting methods for childhood development and fetal growth restriction. A recent conference study used propensity score matching for preterm birth and reported odds ratios. On the right is what we add: a doubly robust analysis of smoking and preterm birth on U.S. birth certificate data, and we report absolute risk differences, an explicit justified DAG, overlap diagnostics and an E-value.</a:t>
+              <a:t>LITERATURE (45 seconds). On the left is what has been done. Smoking raises preterm risk: the largest U.S. study, Liu and colleagues in PLOS Medicine 2020, used about 25.6 million births and found odds ratios from 1.31 at one or two cigarettes a day to 1.53 at twenty or more in the first trimester, building on earlier meta-analysis by Shah and Bracken. Stronger causal designs, such as sibling comparisons, Mendelian randomization and cigarette-tax instruments, mostly study birth weight or fetal growth rather than gestational age. Propensity score methods have been used for birth weight, and doubly robust and weighting methods for childhood development and fetal growth restriction. A recent conference study used propensity score matching for preterm birth and reported odds ratios. On the right is what this study adds: a doubly robust analysis of smoking and preterm birth on U.S. birth certificate data, with absolute risk differences, an explicit justified DAG, overlap diagnostics and an E-value.</a:t>
             </a:r>
             <a:endParaRPr lang="en-US" dirty="0"/>
           </a:p>
@@ -1661,7 +1661,7 @@
           <a:p>
             <a:r>
               <a:rPr lang="en-US" dirty="0"/>
-              <a:t>ASSUMPTIONS (40 seconds). The target, or estimand, is the average treatment effect: the risk of preterm birth if every mother smoked minus the risk if none did. To read our estimate causally we need four things. One, conditional exchangeability: given the ten confounders, smokers and non-smokers would have had the same preterm risk under the same exposure. The DAG is how we argue this, and an E-value tells us how strong an unmeasured confounder would need to be to break it. Two, positivity: every kind of mother has some chance of both smoking and not smoking. We check this with the propensity score overlap and we will be open that it is weak for some mothers. Three, consistency and no interference: 'any smoking' is a coarse exposure covering different doses and timing, and one mother smoking does not change another mother's outcome. Four, for AIPTW specifically, at least one of the two models, propensity or outcome, must be correct. None of these is proven by the data; they are the price of a causal claim.</a:t>
+              <a:t>ASSUMPTIONS (40 seconds). The target, or estimand, is the average treatment effect: the risk of preterm birth if every mother smoked minus the risk if none did. A causal reading of the estimate requires four conditions. One, conditional exchangeability: given the ten confounders, smokers and non-smokers would have had the same preterm risk under the same exposure. The DAG is the argument for this condition, and an E-value quantifies how strong an unmeasured confounder would need to be to violate it. Two, positivity: every kind of mother has some chance of both smoking and not smoking. This is checked with the propensity score overlap, which is weak for some mothers and is reported as such. Three, consistency and no interference: 'any smoking' is a coarse exposure covering different doses and timing, and one mother smoking does not change another mother's outcome. Four, for AIPTW specifically, at least one of the two models, propensity or outcome, must be correct. None of these is proven by the data; they are the price of a causal claim.</a:t>
             </a:r>
             <a:endParaRPr lang="en-US" dirty="0"/>
           </a:p>
@@ -1749,7 +1749,7 @@
           <a:p>
             <a:r>
               <a:rPr lang="en-US" dirty="0"/>
-              <a:t>DAG (45 seconds). This diagram is how the adjustment set was chosen. Smoking, in orange, points to preterm birth, in navy; that arrow is the effect we want. Each of the ten variables on top has an arrow into smoking and an arrow into preterm birth, and each choice is backed by the literature, for example lower education and WIC participation are linked to smoking, and prior preterm birth, diabetes and hypertension are strong predictors of preterm delivery. That creates ten back-door paths, smoking &lt;- X -&gt; preterm. Because every confounder is a direct parent of smoking, conditioning on all ten blocks every back-door path. The blue dashed arrows among the confounders, for example race to education or age to BMI, are plausible relationships, but they do not change which variables we must adjust for. we deliberately left out insurance type, which is shown only in a sensitivity analysis, and we did not adjust for conditions that arise during the pregnancy itself, such as gestational diabetes, because they come after smoking in time. A table with the reason for each edge is in the paper.</a:t>
+              <a:t>DAG (45 seconds). This diagram determines the adjustment set. Smoking, in orange, points to preterm birth, in navy; that arrow is the effect of interest. Each of the ten variables on top has an arrow into smoking and an arrow into preterm birth, and each choice is backed by the literature, for example lower education and WIC participation are linked to smoking, and prior preterm birth, diabetes and hypertension are strong predictors of preterm delivery. That creates ten back-door paths, smoking &lt;- X -&gt; preterm. Because every confounder is a direct parent of smoking, conditioning on all ten blocks every back-door path. The blue dashed arrows among the confounders, for example race to education or age to BMI, are assumed relationships, and they do not change which variables must be adjusted for. Insurance type is deliberately left out of the main model and appears only in a sensitivity analysis, and conditions that arise during the pregnancy itself, such as gestational diabetes, are not adjusted for because they come after smoking in time. A table with the reason for each edge is in the paper.</a:t>
             </a:r>
             <a:endParaRPr lang="en-US" dirty="0"/>
           </a:p>
@@ -1838,12 +1838,12 @@
             <a:r>
               <a:rPr lang="en-US" dirty="0"/>
               <a:t>METHOD (60 seconds on the slide; the calculation below is for your own understanding).
-STEP 1, propensity model. Fit a logistic regression of smoking on the ten confounders: e(X) = P(T=1 | X) = expit(X beta). It gives each mother a probability of smoking. we fit it in base R by iteratively reweighted least squares, and checked it matches glm to about 5e-6.
+STEP 1, propensity model. Fit a logistic regression of smoking on the ten confounders: e(X) = P(T=1 | X) = expit(X beta). It gives each mother a probability of smoking. The model is fitted in base R by iteratively reweighted least squares, and checked it matches glm to about 5e-6.
 STEP 2, outcome models. Fit two logistic regressions for preterm birth, one among smokers, mu1(X) = P(Y=1 | T=1, X), one among non-smokers, mu0(X) = P(Y=1 | T=0, X). Then predict BOTH for every mother, as if she smoked and as if she did not.
-STEP 3, combine. psi1 = mean over all mothers of [ mu1(X) + T (Y - mu1(X)) / e(X) ] and psi0 = mean of [ mu0(X) + (1 - T)(Y - mu0(X)) / (1 - e(X)) ]. The ATE as a risk difference is psi1 - psi0. In words: start from the outcome model prediction, then correct it with the residual of the people who actually received that exposure, weighting the residual by the inverse of their probability of receiving it.
-WORKED EXAMPLE. A smoker with e = 0.06 and mu1 = 0.12. If she delivered preterm (Y=1) her contribution to psi1 is 0.12 + (1 - 0.12)/0.06 = 0.12 + 14.67 = 14.79. If she did not (Y=0) it is 0.12 + (0 - 0.12)/0.06 = -1.88. Average over everyone: if mu1 is correct the residual terms average to zero and we get the outcome-model answer; if mu1 is wrong but e is correct the weighted residuals repair the error, and the other way round. That is double robustness.
-WHY NOT MATCHING. Weighting keeps all 3.26 million births and estimates the effect for the whole population; matching discards unmatched births, changes who the estimate describes, and can increase imbalance and model dependence (King and Nielsen 2019). It also scales easily to millions of rows. Weighting with the propensity score has a long record (Rosenbaum and Rubin 1983) and doubly robust estimation is described by Robins, Rotnitzky and Zhao 1994, Bang and Robins 2005 and Funk and colleagues 2011.
-STANDARD ERRORS. Each mother's contribution minus the average is her influence-function value phi_i; the variance is var(phi)/n. For the risk ratio and odds ratio we use the delta method. A bootstrap on a 200,000-birth subsample (seed 1234) checks these.
+STEP 3, combine. psi1 = mean over all mothers of [ mu1(X) + T (Y - mu1(X)) / e(X) ] and psi0 = mean of [ mu0(X) + (1 - T)(Y - mu0(X)) / (1 - e(X)) ]. The ATE as a risk difference is psi1 - psi0. In words: the outcome model prediction is the starting point, which is then corrected with the residual of the people who actually received that exposure, weighting the residual by the inverse of their probability of receiving it.
+WORKED EXAMPLE. A smoker with e = 0.06 and mu1 = 0.12. If she delivered preterm (Y=1) her contribution to psi1 is 0.12 + (1 - 0.12)/0.06 = 0.12 + 14.67 = 14.79. If she did not (Y=0) it is 0.12 + (0 - 0.12)/0.06 = -1.88. Average over everyone: if mu1 is correct the residual terms average to zero and the outcome-model answer results; if mu1 is wrong but e is correct the weighted residuals repair the error, and the other way round. That is double robustness.
+WHY NOT MATCHING. Weighting keeps all 3.26 million births and estimates the effect for the whole population; matching discards unmatched births, changes who the estimate describes, and can increase imbalance and model dependence (King and Nielsen 2019). Weighting also scales to millions of rows. Weighting with the propensity score has a long record (Rosenbaum and Rubin 1983) and doubly robust estimation is described by Robins, Rotnitzky and Zhao 1994, Bang and Robins 2005 and Funk and colleagues 2011.
+STANDARD ERRORS. Each mother's contribution minus the average is her influence-function value phi_i; the variance is var(phi)/n. For the risk ratio and odds ratio the delta method is used. A bootstrap on a 200,000-birth subsample (seed 1234) checks these.
 PRACTICAL CHOICES. Propensity scores are clamped, not dropped, at the 1st and 99th percentile (0.0002 and 0.163) so extreme weights cannot dominate; sensitivity checks vary this. Five estimators are reported: crude, outcome regression, stabilized IPTW, propensity-score stratification and AIPTW.</a:t>
             </a:r>
             <a:endParaRPr lang="en-US" dirty="0"/>
@@ -2010,7 +2010,7 @@
                   <a:srgbClr val="6A6A6A"/>
                 </a:solidFill>
               </a:rPr>
-              <a:t>SEASUG 2026  |  Paper 103  |  F. Muritala and D. Ghosh</a:t>
+              <a:t>SEASUG 2026  |  F. Muritala and D. Ghosh</a:t>
             </a:r>
             <a:endParaRPr lang="en-US" sz="1000" dirty="0"/>
           </a:p>
@@ -2619,7 +2619,7 @@
                   <a:srgbClr val="FFFFFF"/>
                 </a:solidFill>
               </a:rPr>
-              <a:t>SEASUG 2026  |  Paper 103</a:t>
+              <a:t>SEASUG 2026</a:t>
             </a:r>
             <a:endParaRPr lang="en-US" sz="1800" dirty="0"/>
           </a:p>
@@ -2682,7 +2682,7 @@
                   <a:srgbClr val="1F3864"/>
                 </a:solidFill>
               </a:rPr>
-              <a:t>Diagnostics: overlap is limited, so we report it openly</a:t>
+              <a:t>Diagnostics: limited overlap and covariate balance</a:t>
             </a:r>
             <a:endParaRPr lang="en-US" sz="3000" dirty="0"/>
           </a:p>
@@ -2836,7 +2836,7 @@
                   <a:srgbClr val="1F3864"/>
                 </a:solidFill>
               </a:rPr>
-              <a:t>Dashed lines: 1st and 99th percentiles, where scores are clamped. Consequence: wider interval for the ATE, so we also report the ATT and overlap weights.</a:t>
+              <a:t>Dashed lines: 1st and 99th percentiles, where scores are clamped. Consequence: wider interval for the ATE. The ATT and overlap-weighted estimates are reported alongside.</a:t>
             </a:r>
             <a:endParaRPr lang="en-US" sz="1600" dirty="0"/>
           </a:p>
@@ -2944,7 +2944,7 @@
                   <a:srgbClr val="1F3864"/>
                 </a:solidFill>
               </a:rPr>
-              <a:t>Results: smoking raises preterm risk by about 3.3 points</a:t>
+              <a:t>Results: AIPTW risk difference of about 3.3 points</a:t>
             </a:r>
             <a:endParaRPr lang="en-US" sz="3000" dirty="0"/>
           </a:p>
@@ -3346,7 +3346,7 @@
                   <a:srgbClr val="1F3864"/>
                 </a:solidFill>
               </a:rPr>
-              <a:t>Robustness: the effect holds across analytic choices</a:t>
+              <a:t>Robustness: estimates across analytic choices</a:t>
             </a:r>
             <a:endParaRPr lang="en-US" sz="3000" dirty="0"/>
           </a:p>
@@ -3554,7 +3554,7 @@
                   <a:srgbClr val="1F3864"/>
                 </a:solidFill>
               </a:rPr>
-              <a:t>Conclusion and next steps</a:t>
+              <a:t>Findings and limits</a:t>
             </a:r>
             <a:endParaRPr lang="en-US" sz="3000" dirty="0"/>
           </a:p>
@@ -3615,7 +3615,7 @@
                   <a:srgbClr val="FFFFFF"/>
                 </a:solidFill>
               </a:rPr>
-              <a:t>What we found, and limits</a:t>
+              <a:t>Findings and limits</a:t>
             </a:r>
             <a:endParaRPr lang="en-US" sz="1800" dirty="0"/>
           </a:p>
@@ -3716,7 +3716,7 @@
                   <a:srgbClr val="1F3864"/>
                 </a:solidFill>
               </a:rPr>
-              <a:t>Smoking raises preterm risk by about 3.3 points (RR 1.39)</a:t>
+              <a:t>AIPTW risk difference 3.3 points (RR 1.39), under stated assumptions</a:t>
             </a:r>
             <a:endParaRPr lang="en-US" sz="2000" dirty="0"/>
           </a:p>
@@ -3734,7 +3734,7 @@
                   <a:srgbClr val="2B2B2B"/>
                 </a:solidFill>
               </a:rPr>
-              <a:t>Stable across five estimators and sensitivity checks</a:t>
+              <a:t>3.0 to 3.7 points across adjusted estimators and sensitivity analyses</a:t>
             </a:r>
             <a:endParaRPr lang="en-US" sz="2000" dirty="0"/>
           </a:p>
@@ -6561,7 +6561,7 @@
                   <a:srgbClr val="2B2B2B"/>
                 </a:solidFill>
               </a:rPr>
-              <a:t>Prior preterm birth: 8.9% of smokers vs 3.7% of non-smokers; among non-smokers it raises preterm risk from 7.6% to 26.1%</a:t>
+              <a:t>Prior preterm birth, diabetes and hypertension are more frequent in smokers and carry higher preterm risk (prior preterm birth: 8.9% vs 3.7%; risk 26.1% vs 7.6% among non-smokers)</a:t>
             </a:r>
             <a:endParaRPr lang="en-US" sz="1800" dirty="0"/>
           </a:p>
@@ -6831,7 +6831,7 @@
                   <a:srgbClr val="2B2B2B"/>
                 </a:solidFill>
               </a:rPr>
-              <a:t>Smoking raises preterm risk in 25.6 M U.S. births: odds ratios 1.31 to 1.53 by dose (Liu 2020; Shah &amp; Bracken 2000)</a:t>
+              <a:t>Smoking associated with preterm birth in 25.6 M U.S. births: odds ratios 1.31 to 1.53 by dose (Liu 2020; Shah &amp; Bracken 2000)</a:t>
             </a:r>
             <a:endParaRPr lang="en-US" sz="1600" dirty="0"/>
           </a:p>
@@ -6961,7 +6961,7 @@
                   <a:srgbClr val="2B2B2B"/>
                 </a:solidFill>
               </a:rPr>
-              <a:t>DAG with every edge justified from the literature</a:t>
+              <a:t>DAG with the evidence for every edge documented</a:t>
             </a:r>
             <a:endParaRPr lang="en-US" sz="1800" dirty="0"/>
           </a:p>
@@ -7040,7 +7040,7 @@
                   <a:srgbClr val="1F3864"/>
                 </a:solidFill>
               </a:rPr>
-              <a:t>Gap: causal evidence on preterm birth itself, on the absolute scale, with transparent assumptions and diagnostics.</a:t>
+              <a:t>Gap addressed: a doubly robust estimate for preterm birth itself, on the absolute scale, with stated assumptions and diagnostics.</a:t>
             </a:r>
             <a:endParaRPr lang="en-US" sz="1500" dirty="0"/>
           </a:p>
@@ -7179,16 +7179,40 @@
           </a:ln>
         </p:spPr>
       </p:sp>
-      <p:sp>
-        <p:nvSpPr>
-          <p:cNvPr id="5" name="Text 2"/>
+      <p:pic>
+        <p:nvPicPr>
+          <p:cNvPr id="5" name="Image 0" descr="/tmp/claude-0/-home-claude/af8ec3c4-bb0d-5d0f-a61c-3fed841c0a30/scratchpad/deck/eq/ate_t2.png">    </p:cNvPr>
+          <p:cNvPicPr>
+            <a:picLocks noChangeAspect="1"/>
+          </p:cNvPicPr>
+          <p:nvPr/>
+        </p:nvPicPr>
+        <p:blipFill>
+          <a:blip r:embed="rId1"/>
+          <a:stretch>
+            <a:fillRect/>
+          </a:stretch>
+        </p:blipFill>
+        <p:spPr>
+          <a:xfrm>
+            <a:off x="822960" y="1516075"/>
+            <a:ext cx="3291840" cy="488290"/>
+          </a:xfrm>
+          <a:prstGeom prst="rect">
+            <a:avLst/>
+          </a:prstGeom>
+        </p:spPr>
+      </p:pic>
+      <p:sp>
+        <p:nvSpPr>
+          <p:cNvPr id="6" name="Text 2"/>
           <p:cNvSpPr txBox="1"/>
           <p:nvPr/>
         </p:nvSpPr>
         <p:spPr>
           <a:xfrm>
-            <a:off x="777240" y="1325880"/>
-            <a:ext cx="10607040" cy="868680"/>
+            <a:off x="4389120" y="1325880"/>
+            <a:ext cx="7132320" cy="868680"/>
           </a:xfrm>
           <a:prstGeom prst="rect">
             <a:avLst/>
@@ -7204,20 +7228,20 @@
               <a:buNone/>
             </a:pPr>
             <a:r>
-              <a:rPr lang="en-US" sz="2100" b="1" dirty="0">
+              <a:rPr lang="en-US" sz="1900" b="1" dirty="0">
                 <a:solidFill>
                   <a:srgbClr val="FFFFFF"/>
                 </a:solidFill>
               </a:rPr>
-              <a:t>ATE = E[ Y(1) ] - E[ Y(0) ]: risk of preterm birth if every mother smoked minus the risk if none did</a:t>
-            </a:r>
-            <a:endParaRPr lang="en-US" sz="2100" dirty="0"/>
-          </a:p>
-        </p:txBody>
-      </p:sp>
-      <p:sp>
-        <p:nvSpPr>
-          <p:cNvPr id="6" name="Shape 3"/>
+              <a:t>Risk of preterm birth if every mother smoked minus the risk if none did</a:t>
+            </a:r>
+            <a:endParaRPr lang="en-US" sz="1900" dirty="0"/>
+          </a:p>
+        </p:txBody>
+      </p:sp>
+      <p:sp>
+        <p:nvSpPr>
+          <p:cNvPr id="7" name="Shape 3"/>
           <p:cNvSpPr/>
           <p:nvPr/>
         </p:nvSpPr>
@@ -7242,7 +7266,7 @@
       </p:sp>
       <p:sp>
         <p:nvSpPr>
-          <p:cNvPr id="7" name="Shape 4"/>
+          <p:cNvPr id="8" name="Shape 4"/>
           <p:cNvSpPr/>
           <p:nvPr/>
         </p:nvSpPr>
@@ -7267,7 +7291,7 @@
       </p:sp>
       <p:sp>
         <p:nvSpPr>
-          <p:cNvPr id="8" name="Text 5"/>
+          <p:cNvPr id="9" name="Text 5"/>
           <p:cNvSpPr txBox="1"/>
           <p:nvPr/>
         </p:nvSpPr>
@@ -7303,7 +7327,7 @@
       </p:sp>
       <p:sp>
         <p:nvSpPr>
-          <p:cNvPr id="9" name="Text 6"/>
+          <p:cNvPr id="10" name="Text 6"/>
           <p:cNvSpPr txBox="1"/>
           <p:nvPr/>
         </p:nvSpPr>
@@ -7331,7 +7355,7 @@
                   <a:srgbClr val="2B2B2B"/>
                 </a:solidFill>
               </a:rPr>
-              <a:t>Y(t) independent of T given X. The ten DAG confounders block every back-door path. Untestable, so we add an E-value.</a:t>
+              <a:t>Y(t) independent of T given X. The ten DAG confounders block every back-door path. Untestable; an E-value is reported.</a:t>
             </a:r>
             <a:endParaRPr lang="en-US" sz="1600" dirty="0"/>
           </a:p>
@@ -7339,7 +7363,7 @@
       </p:sp>
       <p:sp>
         <p:nvSpPr>
-          <p:cNvPr id="10" name="Shape 7"/>
+          <p:cNvPr id="11" name="Shape 7"/>
           <p:cNvSpPr/>
           <p:nvPr/>
         </p:nvSpPr>
@@ -7364,7 +7388,7 @@
       </p:sp>
       <p:sp>
         <p:nvSpPr>
-          <p:cNvPr id="11" name="Shape 8"/>
+          <p:cNvPr id="12" name="Shape 8"/>
           <p:cNvSpPr/>
           <p:nvPr/>
         </p:nvSpPr>
@@ -7389,7 +7413,7 @@
       </p:sp>
       <p:sp>
         <p:nvSpPr>
-          <p:cNvPr id="12" name="Text 9"/>
+          <p:cNvPr id="13" name="Text 9"/>
           <p:cNvSpPr txBox="1"/>
           <p:nvPr/>
         </p:nvSpPr>
@@ -7425,7 +7449,7 @@
       </p:sp>
       <p:sp>
         <p:nvSpPr>
-          <p:cNvPr id="13" name="Text 10"/>
+          <p:cNvPr id="14" name="Text 10"/>
           <p:cNvSpPr txBox="1"/>
           <p:nvPr/>
         </p:nvSpPr>
@@ -7461,7 +7485,7 @@
       </p:sp>
       <p:sp>
         <p:nvSpPr>
-          <p:cNvPr id="14" name="Shape 11"/>
+          <p:cNvPr id="15" name="Shape 11"/>
           <p:cNvSpPr/>
           <p:nvPr/>
         </p:nvSpPr>
@@ -7486,7 +7510,7 @@
       </p:sp>
       <p:sp>
         <p:nvSpPr>
-          <p:cNvPr id="15" name="Shape 12"/>
+          <p:cNvPr id="16" name="Shape 12"/>
           <p:cNvSpPr/>
           <p:nvPr/>
         </p:nvSpPr>
@@ -7511,7 +7535,7 @@
       </p:sp>
       <p:sp>
         <p:nvSpPr>
-          <p:cNvPr id="16" name="Text 13"/>
+          <p:cNvPr id="17" name="Text 13"/>
           <p:cNvSpPr txBox="1"/>
           <p:nvPr/>
         </p:nvSpPr>
@@ -7547,7 +7571,7 @@
       </p:sp>
       <p:sp>
         <p:nvSpPr>
-          <p:cNvPr id="17" name="Text 14"/>
+          <p:cNvPr id="18" name="Text 14"/>
           <p:cNvSpPr txBox="1"/>
           <p:nvPr/>
         </p:nvSpPr>
@@ -7583,7 +7607,7 @@
       </p:sp>
       <p:sp>
         <p:nvSpPr>
-          <p:cNvPr id="18" name="Shape 15"/>
+          <p:cNvPr id="19" name="Shape 15"/>
           <p:cNvSpPr/>
           <p:nvPr/>
         </p:nvSpPr>
@@ -7608,7 +7632,7 @@
       </p:sp>
       <p:sp>
         <p:nvSpPr>
-          <p:cNvPr id="19" name="Shape 16"/>
+          <p:cNvPr id="20" name="Shape 16"/>
           <p:cNvSpPr/>
           <p:nvPr/>
         </p:nvSpPr>
@@ -7633,7 +7657,7 @@
       </p:sp>
       <p:sp>
         <p:nvSpPr>
-          <p:cNvPr id="20" name="Text 17"/>
+          <p:cNvPr id="21" name="Text 17"/>
           <p:cNvSpPr txBox="1"/>
           <p:nvPr/>
         </p:nvSpPr>
@@ -7669,7 +7693,7 @@
       </p:sp>
       <p:sp>
         <p:nvSpPr>
-          <p:cNvPr id="21" name="Text 18"/>
+          <p:cNvPr id="22" name="Text 18"/>
           <p:cNvSpPr txBox="1"/>
           <p:nvPr/>
         </p:nvSpPr>
@@ -8159,7 +8183,7 @@
                   <a:srgbClr val="2B2B2B"/>
                 </a:solidFill>
               </a:rPr>
-              <a:t>mu1(X), mu0(X) = chance of preterm birth if smoking / not smoking</a:t>
+              <a:t>μ1(X), μ0(X) = chance of preterm birth if smoking / not smoking</a:t>
             </a:r>
             <a:endParaRPr lang="en-US" sz="1900" dirty="0"/>
           </a:p>
@@ -8270,7 +8294,7 @@
                   <a:srgbClr val="2B2B2B"/>
                 </a:solidFill>
               </a:rPr>
-              <a:t>Outcome prediction + weighted residual; ATE = psi1 - psi0</a:t>
+              <a:t>Outcome prediction + weighted residual; ATE = ψ1 - ψ0</a:t>
             </a:r>
             <a:endParaRPr lang="en-US" sz="1900" dirty="0"/>
           </a:p>
@@ -8284,8 +8308,8 @@
         </p:nvSpPr>
         <p:spPr>
           <a:xfrm>
-            <a:off x="548640" y="5349240"/>
-            <a:ext cx="5943600" cy="777240"/>
+            <a:off x="548640" y="4892040"/>
+            <a:ext cx="5943600" cy="1371600"/>
           </a:xfrm>
           <a:prstGeom prst="rect">
             <a:avLst/>
@@ -8301,45 +8325,33 @@
           </a:ln>
         </p:spPr>
       </p:sp>
-      <p:sp>
-        <p:nvSpPr>
-          <p:cNvPr id="14" name="Text 11"/>
-          <p:cNvSpPr txBox="1"/>
-          <p:nvPr/>
-        </p:nvSpPr>
-        <p:spPr>
-          <a:xfrm>
-            <a:off x="640080" y="5349240"/>
-            <a:ext cx="5760720" cy="777240"/>
-          </a:xfrm>
-          <a:prstGeom prst="rect">
-            <a:avLst/>
-          </a:prstGeom>
-          <a:noFill/>
-          <a:ln/>
-        </p:spPr>
-        <p:txBody>
-          <a:bodyPr wrap="square" lIns="0" tIns="0" rIns="0" bIns="0" rtlCol="0" anchor="ctr"/>
-          <a:lstStyle/>
-          <a:p>
-            <a:pPr algn="ctr" indent="0" marL="0">
-              <a:buNone/>
-            </a:pPr>
-            <a:r>
-              <a:rPr lang="en-US" sz="1300" b="1" dirty="0">
-                <a:solidFill>
-                  <a:srgbClr val="1F3864"/>
-                </a:solidFill>
-              </a:rPr>
-              <a:t>psi1 = mean[ mu1 + T (Y - mu1) / e ]      psi0 = mean[ mu0 + (1 - T)(Y - mu0) / (1 - e) ]</a:t>
-            </a:r>
-            <a:endParaRPr lang="en-US" sz="1300" dirty="0"/>
-          </a:p>
-        </p:txBody>
-      </p:sp>
-      <p:sp>
-        <p:nvSpPr>
-          <p:cNvPr id="15" name="Shape 12"/>
+      <p:pic>
+        <p:nvPicPr>
+          <p:cNvPr id="14" name="Image 0" descr="/tmp/claude-0/-home-claude/af8ec3c4-bb0d-5d0f-a61c-3fed841c0a30/scratchpad/deck/eq/st_t.png">    </p:cNvPr>
+          <p:cNvPicPr>
+            <a:picLocks noChangeAspect="1"/>
+          </p:cNvPicPr>
+          <p:nvPr/>
+        </p:nvPicPr>
+        <p:blipFill>
+          <a:blip r:embed="rId1"/>
+          <a:stretch>
+            <a:fillRect/>
+          </a:stretch>
+        </p:blipFill>
+        <p:spPr>
+          <a:xfrm>
+            <a:off x="1783080" y="4937760"/>
+            <a:ext cx="3474720" cy="1268820"/>
+          </a:xfrm>
+          <a:prstGeom prst="rect">
+            <a:avLst/>
+          </a:prstGeom>
+        </p:spPr>
+      </p:pic>
+      <p:sp>
+        <p:nvSpPr>
+          <p:cNvPr id="15" name="Shape 11"/>
           <p:cNvSpPr/>
           <p:nvPr/>
         </p:nvSpPr>
@@ -8364,7 +8376,7 @@
       </p:sp>
       <p:sp>
         <p:nvSpPr>
-          <p:cNvPr id="16" name="Text 13"/>
+          <p:cNvPr id="16" name="Text 12"/>
           <p:cNvSpPr txBox="1"/>
           <p:nvPr/>
         </p:nvSpPr>
@@ -8400,7 +8412,7 @@
       </p:sp>
       <p:sp>
         <p:nvSpPr>
-          <p:cNvPr id="17" name="Text 14"/>
+          <p:cNvPr id="17" name="Text 13"/>
           <p:cNvSpPr txBox="1"/>
           <p:nvPr/>
         </p:nvSpPr>

</xml_diff>